<commit_message>
WIP: uncommitted changes, moved to the cloud
Snapshot of the working tree the Claude desktop app took to continue
this session in the cloud. It was never committed on the desktop; fold
it into your next commit (git commit --amend) or unstage it
(git reset --mixed HEAD~1) before committing for real.
</commit_message>
<xml_diff>
--- a/docs/CareerStar-CapitalOne-v10.pptx
+++ b/docs/CareerStar-CapitalOne-v10.pptx
@@ -1220,7 +1220,8 @@
           <a:p>
             <a:r>
               <a:rPr lang="en-US" dirty="0"/>
-              <a:t>Let me show the product first so everything later has something to hang on. You type in the careers you're deciding between — say nursing versus software versus actuary — and each one gets a score out of 100. Higher means a stronger bet.
+              <a:t>First, what this project is and why I made it. Everyone I know is in the middle of picking a major or a career path, right while AI is reshuffling what those careers will look like. And when you search something like 'is nursing a safe career?', the internet gives you one of two things: a pep talk, or a doom score from a quiz — vibes, either way. What I wanted was the kind of answer an analyst gives about a stock: real numbers, named sources, and an honest 'it's close' when it's close. Nobody had built that, so I did.
+So here's what it is. You type in the careers you're deciding between — say nursing versus software versus actuary — and each one gets a score out of 100. Higher means a stronger bet, and the reasoning is shown, not hidden.
 Where do the numbers come from? The U.S. government, mostly. The Bureau of Labor Statistics — the agency that tracks the job market — publishes data on about 730 occupations: how many people work in each one, how fast it's expected to grow over the next decade, and what it typically pays. A second government database, O*NET, describes the skills each job actually uses day to day. And a published research study estimated, job by job, how much of the work today's AI could already do. My site combines those public sources — I didn't collect anything myself, which is the point: you can check my inputs.
 Why five formulas? Because my formula is one opinion about how to weigh all that, and reasonable people would weigh it differently. So the site ships five: the Standard one — my headline formula, reward marked down by AI risk. The Growth optimist — just growth and pay, deliberately ignoring AI, betting the official forecasts already account for it. The Defensive one — safety first: if AI hits hard, how sheltered is this career? The Efficiency one — reward per unit of risk; a career has to earn its risk. And the Plain average — it just averages everything, and it exists as the baseline: if my clever formula can't beat a plain average, I want to know. You can switch between them live, and when they disagree, that disagreement is real information about uncertainty.
 And the stars: they're graded on a curve, the way Morningstar rates mutual funds. Five stars doesn't mean 'nice job' — it means 'top 10 percent of all 730.' If most careers could get five stars, stars would mean nothing. Scarcity is what makes them information. (2:00)</a:t>
@@ -2432,7 +2433,7 @@
         </p:blipFill>
         <p:spPr>
           <a:xfrm>
-            <a:off x="5769864" y="1298448"/>
+            <a:off x="5769864" y="1207008"/>
             <a:ext cx="621792" cy="649224"/>
           </a:xfrm>
           <a:prstGeom prst="rect">
@@ -2444,30 +2445,28 @@
         <p:nvSpPr>
           <p:cNvPr id="3" name="Text 0"/>
           <p:cNvSpPr/>
-          <p:nvPr>
-            <p:ph idx="100" type="title" hasCustomPrompt="1"/>
-          </p:nvPr>
-        </p:nvSpPr>
-        <p:spPr>
-          <a:xfrm>
-            <a:off x="1527048" y="1965960"/>
-            <a:ext cx="9144000" cy="1005840"/>
-          </a:xfrm>
-          <a:prstGeom prst="rect">
-            <a:avLst/>
-          </a:prstGeom>
-          <a:noFill/>
-          <a:ln/>
-        </p:spPr>
-        <p:txBody>
-          <a:bodyPr wrap="square" lIns="0" tIns="0" rIns="0" bIns="0" rtlCol="0"/>
+          <p:nvPr/>
+        </p:nvSpPr>
+        <p:spPr>
+          <a:xfrm>
+            <a:off x="1069848" y="1965960"/>
+            <a:ext cx="10058400" cy="1920240"/>
+          </a:xfrm>
+          <a:prstGeom prst="rect">
+            <a:avLst/>
+          </a:prstGeom>
+          <a:noFill/>
+          <a:ln/>
+        </p:spPr>
+        <p:txBody>
+          <a:bodyPr wrap="square" lIns="0" tIns="0" rIns="0" bIns="0" rtlCol="0" anchor="t"/>
           <a:lstStyle/>
           <a:p>
             <a:pPr algn="ctr" indent="0" marL="0">
               <a:buNone/>
             </a:pPr>
             <a:r>
-              <a:rPr lang="en-US" sz="4400" b="1" dirty="0">
+              <a:rPr lang="en-US" sz="4200" b="1" dirty="0">
                 <a:solidFill>
                   <a:srgbClr val="FFFFFF"/>
                 </a:solidFill>
@@ -2475,56 +2474,55 @@
                 <a:ea typeface="Arial" pitchFamily="34" charset="-122"/>
                 <a:cs typeface="Arial" pitchFamily="34" charset="-120"/>
               </a:rPr>
-              <a:t>Rating careers like stocks</a:t>
-            </a:r>
-            <a:endParaRPr lang="en-US" sz="4400" dirty="0"/>
-          </a:p>
-        </p:txBody>
-      </p:sp>
-      <p:sp>
-        <p:nvSpPr>
-          <p:cNvPr id="4" name="Text 0"/>
-          <p:cNvSpPr/>
-          <p:nvPr>
-            <p:ph idx="101" type="body" hasCustomPrompt="1"/>
-          </p:nvPr>
-        </p:nvSpPr>
-        <p:spPr>
-          <a:xfrm>
-            <a:off x="1527048" y="3063240"/>
-            <a:ext cx="9144000" cy="822960"/>
-          </a:xfrm>
-          <a:prstGeom prst="rect">
-            <a:avLst/>
-          </a:prstGeom>
-          <a:noFill/>
-          <a:ln/>
-        </p:spPr>
-        <p:txBody>
-          <a:bodyPr wrap="square" lIns="0" tIns="0" rIns="0" bIns="0" rtlCol="0"/>
-          <a:lstStyle/>
+              <a:t>Rating careers like stocks:</a:t>
+            </a:r>
+            <a:endParaRPr lang="en-US" sz="4200" dirty="0"/>
+          </a:p>
           <a:p>
             <a:pPr algn="ctr" indent="0" marL="0">
               <a:buNone/>
             </a:pPr>
-            <a:r>
-              <a:rPr lang="en-US" sz="1800" dirty="0">
-                <a:solidFill>
-                  <a:srgbClr val="9DB0D9"/>
-                </a:solidFill>
-                <a:latin typeface="Arial" pitchFamily="34" charset="0"/>
-                <a:ea typeface="Arial" pitchFamily="34" charset="-122"/>
-                <a:cs typeface="Arial" pitchFamily="34" charset="-120"/>
-              </a:rPr>
-              <a:t>Exploring development with the BMAD AI agentic framework — and how to host a simple website on AWS.</a:t>
-            </a:r>
-            <a:endParaRPr lang="en-US" sz="1800" dirty="0"/>
-          </a:p>
-        </p:txBody>
-      </p:sp>
-      <p:sp>
-        <p:nvSpPr>
-          <p:cNvPr id="5" name="Shape 2"/>
+            <a:endParaRPr lang="en-US" sz="4200" dirty="0"/>
+          </a:p>
+          <a:p>
+            <a:pPr algn="ctr" indent="0" marL="0">
+              <a:buNone/>
+            </a:pPr>
+            <a:r>
+              <a:rPr lang="en-US" sz="2300" b="1" dirty="0">
+                <a:solidFill>
+                  <a:srgbClr val="E8EEFC"/>
+                </a:solidFill>
+                <a:latin typeface="Arial" pitchFamily="34" charset="0"/>
+                <a:ea typeface="Arial" pitchFamily="34" charset="-122"/>
+                <a:cs typeface="Arial" pitchFamily="34" charset="-120"/>
+              </a:rPr>
+              <a:t>Exploring development with the BMAD AI agentic framework,</a:t>
+            </a:r>
+            <a:endParaRPr lang="en-US" sz="4200" dirty="0"/>
+          </a:p>
+          <a:p>
+            <a:pPr algn="ctr" indent="0" marL="0">
+              <a:buNone/>
+            </a:pPr>
+            <a:r>
+              <a:rPr lang="en-US" sz="2300" b="1" dirty="0">
+                <a:solidFill>
+                  <a:srgbClr val="E8EEFC"/>
+                </a:solidFill>
+                <a:latin typeface="Arial" pitchFamily="34" charset="0"/>
+                <a:ea typeface="Arial" pitchFamily="34" charset="-122"/>
+                <a:cs typeface="Arial" pitchFamily="34" charset="-120"/>
+              </a:rPr>
+              <a:t>and how to host a simple website on AWS</a:t>
+            </a:r>
+            <a:endParaRPr lang="en-US" sz="4200" dirty="0"/>
+          </a:p>
+        </p:txBody>
+      </p:sp>
+      <p:sp>
+        <p:nvSpPr>
+          <p:cNvPr id="4" name="Shape 1"/>
           <p:cNvSpPr/>
           <p:nvPr/>
         </p:nvSpPr>
@@ -2544,7 +2542,7 @@
       </p:sp>
       <p:sp>
         <p:nvSpPr>
-          <p:cNvPr id="6" name="Text 3"/>
+          <p:cNvPr id="5" name="Text 2"/>
           <p:cNvSpPr/>
           <p:nvPr/>
         </p:nvSpPr>
@@ -2621,6 +2619,66 @@
               <a:t>Capital One · August 6, 2026</a:t>
             </a:r>
             <a:endParaRPr lang="en-US" sz="1500" dirty="0"/>
+          </a:p>
+        </p:txBody>
+      </p:sp>
+      <p:sp>
+        <p:nvSpPr>
+          <p:cNvPr id="7" name="Text 0"/>
+          <p:cNvSpPr/>
+          <p:nvPr>
+            <p:ph idx="100" type="title" hasCustomPrompt="1"/>
+          </p:nvPr>
+        </p:nvSpPr>
+        <p:spPr>
+          <a:xfrm>
+            <a:off x="1527048" y="1965960"/>
+            <a:ext cx="9144000" cy="1005840"/>
+          </a:xfrm>
+          <a:prstGeom prst="rect">
+            <a:avLst/>
+          </a:prstGeom>
+          <a:noFill/>
+          <a:ln/>
+        </p:spPr>
+        <p:txBody>
+          <a:bodyPr wrap="square" rtlCol="0"/>
+          <a:lstStyle/>
+          <a:p>
+            <a:pPr indent="0" marL="0">
+              <a:buNone/>
+            </a:pPr>
+            <a:endParaRPr lang="en-US" dirty="0"/>
+          </a:p>
+        </p:txBody>
+      </p:sp>
+      <p:sp>
+        <p:nvSpPr>
+          <p:cNvPr id="8" name="Text 0"/>
+          <p:cNvSpPr/>
+          <p:nvPr>
+            <p:ph idx="101" type="body" hasCustomPrompt="1"/>
+          </p:nvPr>
+        </p:nvSpPr>
+        <p:spPr>
+          <a:xfrm>
+            <a:off x="1527048" y="3063240"/>
+            <a:ext cx="9144000" cy="822960"/>
+          </a:xfrm>
+          <a:prstGeom prst="rect">
+            <a:avLst/>
+          </a:prstGeom>
+          <a:noFill/>
+          <a:ln/>
+        </p:spPr>
+        <p:txBody>
+          <a:bodyPr wrap="square" rtlCol="0"/>
+          <a:lstStyle/>
+          <a:p>
+            <a:pPr indent="0" marL="0">
+              <a:buNone/>
+            </a:pPr>
+            <a:endParaRPr lang="en-US" dirty="0"/>
           </a:p>
         </p:txBody>
       </p:sp>
@@ -6085,7 +6143,7 @@
                 <a:ea typeface="Arial" pitchFamily="34" charset="-122"/>
                 <a:cs typeface="Arial" pitchFamily="34" charset="-120"/>
               </a:rPr>
-              <a:t>02 · WHAT IT DOES</a:t>
+              <a:t>02 · WHAT IT IS, AND WHY</a:t>
             </a:r>
             <a:endParaRPr lang="en-US" sz="1400" dirty="0"/>
           </a:p>
@@ -6126,15 +6184,68 @@
                 <a:ea typeface="Arial" pitchFamily="34" charset="-122"/>
                 <a:cs typeface="Arial" pitchFamily="34" charset="-120"/>
               </a:rPr>
-              <a:t>Type in careers, get a score out of 100 for each</a:t>
+              <a:t>CareerStar: what it is, and why I built it</a:t>
             </a:r>
             <a:endParaRPr lang="en-US" sz="3000" dirty="0"/>
+          </a:p>
+        </p:txBody>
+      </p:sp>
+      <p:sp>
+        <p:nvSpPr>
+          <p:cNvPr id="5" name="Text 2"/>
+          <p:cNvSpPr/>
+          <p:nvPr/>
+        </p:nvSpPr>
+        <p:spPr>
+          <a:xfrm>
+            <a:off x="640080" y="1810512"/>
+            <a:ext cx="10911535" cy="603504"/>
+          </a:xfrm>
+          <a:prstGeom prst="rect">
+            <a:avLst/>
+          </a:prstGeom>
+          <a:noFill/>
+          <a:ln/>
+        </p:spPr>
+        <p:txBody>
+          <a:bodyPr wrap="square" lIns="0" tIns="0" rIns="0" bIns="0" rtlCol="0" anchor="t"/>
+          <a:lstStyle/>
+          <a:p>
+            <a:pPr algn="l" indent="0" marL="0">
+              <a:buNone/>
+            </a:pPr>
+            <a:r>
+              <a:rPr lang="en-US" sz="1500" dirty="0">
+                <a:solidFill>
+                  <a:srgbClr val="64748B"/>
+                </a:solidFill>
+                <a:latin typeface="Arial" pitchFamily="34" charset="0"/>
+                <a:ea typeface="Arial" pitchFamily="34" charset="-122"/>
+                <a:cs typeface="Arial" pitchFamily="34" charset="-120"/>
+              </a:rPr>
+              <a:t>People my age are picking careers while AI reshuffles them — and the internet’s answers are either pep talks or doom scores. </a:t>
+            </a:r>
+            <a:pPr algn="l" indent="0" marL="0">
+              <a:buNone/>
+            </a:pPr>
+            <a:r>
+              <a:rPr lang="en-US" sz="1500" b="1" dirty="0">
+                <a:solidFill>
+                  <a:srgbClr val="0F172A"/>
+                </a:solidFill>
+                <a:latin typeface="Arial" pitchFamily="34" charset="0"/>
+                <a:ea typeface="Arial" pitchFamily="34" charset="-122"/>
+                <a:cs typeface="Arial" pitchFamily="34" charset="-120"/>
+              </a:rPr>
+              <a:t>So I built the tool I wanted: type in the careers you’re weighing, get a score out of 100 for each, with the reasoning shown.</a:t>
+            </a:r>
+            <a:endParaRPr lang="en-US" sz="1500" dirty="0"/>
           </a:p>
         </p:txBody>
       </p:sp>
       <p:pic>
         <p:nvPicPr>
-          <p:cNvPr id="5" name="Image 1" descr="preencoded.png">    </p:cNvPr>
+          <p:cNvPr id="6" name="Image 1" descr="preencoded.png">    </p:cNvPr>
           <p:cNvPicPr>
             <a:picLocks noChangeAspect="1"/>
           </p:cNvPicPr>
@@ -6148,8 +6259,8 @@
         </p:blipFill>
         <p:spPr>
           <a:xfrm>
-            <a:off x="640080" y="1828800"/>
-            <a:ext cx="3890648" cy="4160520"/>
+            <a:off x="640080" y="2514600"/>
+            <a:ext cx="3377596" cy="3611880"/>
           </a:xfrm>
           <a:prstGeom prst="rect">
             <a:avLst/>
@@ -6158,14 +6269,14 @@
       </p:pic>
       <p:sp>
         <p:nvSpPr>
-          <p:cNvPr id="6" name="Shape 2"/>
-          <p:cNvSpPr/>
-          <p:nvPr/>
-        </p:nvSpPr>
-        <p:spPr>
-          <a:xfrm>
-            <a:off x="621792" y="1810512"/>
-            <a:ext cx="3927224" cy="4197096"/>
+          <p:cNvPr id="7" name="Shape 3"/>
+          <p:cNvSpPr/>
+          <p:nvPr/>
+        </p:nvSpPr>
+        <p:spPr>
+          <a:xfrm>
+            <a:off x="621792" y="2496312"/>
+            <a:ext cx="3414172" cy="3648456"/>
           </a:xfrm>
           <a:prstGeom prst="rect">
             <a:avLst/>
@@ -6185,14 +6296,14 @@
       </p:sp>
       <p:sp>
         <p:nvSpPr>
-          <p:cNvPr id="7" name="Text 3"/>
-          <p:cNvSpPr/>
-          <p:nvPr/>
-        </p:nvSpPr>
-        <p:spPr>
-          <a:xfrm>
-            <a:off x="640080" y="6053328"/>
-            <a:ext cx="4805048" cy="274320"/>
+          <p:cNvPr id="8" name="Text 4"/>
+          <p:cNvSpPr/>
+          <p:nvPr/>
+        </p:nvSpPr>
+        <p:spPr>
+          <a:xfrm>
+            <a:off x="640080" y="6217920"/>
+            <a:ext cx="3560476" cy="274320"/>
           </a:xfrm>
           <a:prstGeom prst="rect">
             <a:avLst/>
@@ -6216,22 +6327,22 @@
                 <a:ea typeface="Arial" pitchFamily="34" charset="-122"/>
                 <a:cs typeface="Arial" pitchFamily="34" charset="-120"/>
               </a:rPr>
-              <a:t>ashleylibasci.com/rate — the real site, as it looks today</a:t>
-            </a:r>
-            <a:endParaRPr lang="en-US" sz="1500" dirty="0"/>
-          </a:p>
-        </p:txBody>
-      </p:sp>
-      <p:sp>
-        <p:nvSpPr>
-          <p:cNvPr id="8" name="Text 4"/>
-          <p:cNvSpPr/>
-          <p:nvPr/>
-        </p:nvSpPr>
-        <p:spPr>
-          <a:xfrm>
-            <a:off x="4800600" y="2075688"/>
-            <a:ext cx="1371600" cy="566928"/>
+              <a:t>ashleylibasci.com/rate — the live site</a:t>
+            </a:r>
+            <a:endParaRPr lang="en-US" sz="1500" dirty="0"/>
+          </a:p>
+        </p:txBody>
+      </p:sp>
+      <p:sp>
+        <p:nvSpPr>
+          <p:cNvPr id="9" name="Text 5"/>
+          <p:cNvSpPr/>
+          <p:nvPr/>
+        </p:nvSpPr>
+        <p:spPr>
+          <a:xfrm>
+            <a:off x="4434840" y="2624328"/>
+            <a:ext cx="1325880" cy="548640"/>
           </a:xfrm>
           <a:prstGeom prst="rect">
             <a:avLst/>
@@ -6247,7 +6358,7 @@
               <a:buNone/>
             </a:pPr>
             <a:r>
-              <a:rPr lang="en-US" sz="3600" b="1" dirty="0">
+              <a:rPr lang="en-US" sz="3400" b="1" dirty="0">
                 <a:solidFill>
                   <a:srgbClr val="1D4ED8"/>
                 </a:solidFill>
@@ -6263,14 +6374,14 @@
       </p:sp>
       <p:sp>
         <p:nvSpPr>
-          <p:cNvPr id="9" name="Text 5"/>
-          <p:cNvSpPr/>
-          <p:nvPr/>
-        </p:nvSpPr>
-        <p:spPr>
-          <a:xfrm>
-            <a:off x="6263640" y="2167128"/>
-            <a:ext cx="5285232" cy="685800"/>
+          <p:cNvPr id="10" name="Text 6"/>
+          <p:cNvSpPr/>
+          <p:nvPr/>
+        </p:nvSpPr>
+        <p:spPr>
+          <a:xfrm>
+            <a:off x="5806440" y="2715768"/>
+            <a:ext cx="5742432" cy="685800"/>
           </a:xfrm>
           <a:prstGeom prst="rect">
             <a:avLst/>
@@ -6286,7 +6397,7 @@
               <a:buNone/>
             </a:pPr>
             <a:r>
-              <a:rPr lang="en-US" sz="1600" dirty="0">
+              <a:rPr lang="en-US" sz="1500" dirty="0">
                 <a:solidFill>
                   <a:srgbClr val="0F172A"/>
                 </a:solidFill>
@@ -6294,22 +6405,22 @@
                 <a:ea typeface="Arial" pitchFamily="34" charset="-122"/>
                 <a:cs typeface="Arial" pitchFamily="34" charset="-120"/>
               </a:rPr>
-              <a:t>occupations scored — every job the U.S. Labor Department publishes numbers on: how many people do it, expected growth, typical pay</a:t>
-            </a:r>
-            <a:endParaRPr lang="en-US" sz="1500" dirty="0"/>
-          </a:p>
-        </p:txBody>
-      </p:sp>
-      <p:sp>
-        <p:nvSpPr>
-          <p:cNvPr id="10" name="Shape 6"/>
-          <p:cNvSpPr/>
-          <p:nvPr/>
-        </p:nvSpPr>
-        <p:spPr>
-          <a:xfrm>
-            <a:off x="4800600" y="2953512"/>
-            <a:ext cx="6748272" cy="12802"/>
+              <a:t>occupations scored — every job the U.S. Labor Department publishes numbers on: headcount, expected growth, typical pay</a:t>
+            </a:r>
+            <a:endParaRPr lang="en-US" sz="1500" dirty="0"/>
+          </a:p>
+        </p:txBody>
+      </p:sp>
+      <p:sp>
+        <p:nvSpPr>
+          <p:cNvPr id="11" name="Shape 7"/>
+          <p:cNvSpPr/>
+          <p:nvPr/>
+        </p:nvSpPr>
+        <p:spPr>
+          <a:xfrm>
+            <a:off x="4434840" y="3483864"/>
+            <a:ext cx="7114032" cy="12802"/>
           </a:xfrm>
           <a:prstGeom prst="rect">
             <a:avLst/>
@@ -6322,14 +6433,14 @@
       </p:sp>
       <p:sp>
         <p:nvSpPr>
-          <p:cNvPr id="11" name="Text 7"/>
-          <p:cNvSpPr/>
-          <p:nvPr/>
-        </p:nvSpPr>
-        <p:spPr>
-          <a:xfrm>
-            <a:off x="4800600" y="3099816"/>
-            <a:ext cx="1371600" cy="566928"/>
+          <p:cNvPr id="12" name="Text 8"/>
+          <p:cNvSpPr/>
+          <p:nvPr/>
+        </p:nvSpPr>
+        <p:spPr>
+          <a:xfrm>
+            <a:off x="4434840" y="3630168"/>
+            <a:ext cx="1325880" cy="548640"/>
           </a:xfrm>
           <a:prstGeom prst="rect">
             <a:avLst/>
@@ -6345,7 +6456,7 @@
               <a:buNone/>
             </a:pPr>
             <a:r>
-              <a:rPr lang="en-US" sz="3600" b="1" dirty="0">
+              <a:rPr lang="en-US" sz="3400" b="1" dirty="0">
                 <a:solidFill>
                   <a:srgbClr val="1D4ED8"/>
                 </a:solidFill>
@@ -6361,14 +6472,14 @@
       </p:sp>
       <p:sp>
         <p:nvSpPr>
-          <p:cNvPr id="12" name="Text 8"/>
-          <p:cNvSpPr/>
-          <p:nvPr/>
-        </p:nvSpPr>
-        <p:spPr>
-          <a:xfrm>
-            <a:off x="6263640" y="3191256"/>
-            <a:ext cx="5285232" cy="685800"/>
+          <p:cNvPr id="13" name="Text 9"/>
+          <p:cNvSpPr/>
+          <p:nvPr/>
+        </p:nvSpPr>
+        <p:spPr>
+          <a:xfrm>
+            <a:off x="5806440" y="3721608"/>
+            <a:ext cx="5742432" cy="685800"/>
           </a:xfrm>
           <a:prstGeom prst="rect">
             <a:avLst/>
@@ -6384,7 +6495,7 @@
               <a:buNone/>
             </a:pPr>
             <a:r>
-              <a:rPr lang="en-US" sz="1600" dirty="0">
+              <a:rPr lang="en-US" sz="1500" dirty="0">
                 <a:solidFill>
                   <a:srgbClr val="0F172A"/>
                 </a:solidFill>
@@ -6400,14 +6511,14 @@
       </p:sp>
       <p:sp>
         <p:nvSpPr>
-          <p:cNvPr id="13" name="Shape 9"/>
-          <p:cNvSpPr/>
-          <p:nvPr/>
-        </p:nvSpPr>
-        <p:spPr>
-          <a:xfrm>
-            <a:off x="4800600" y="3977640"/>
-            <a:ext cx="6748272" cy="12802"/>
+          <p:cNvPr id="14" name="Shape 10"/>
+          <p:cNvSpPr/>
+          <p:nvPr/>
+        </p:nvSpPr>
+        <p:spPr>
+          <a:xfrm>
+            <a:off x="4434840" y="4489704"/>
+            <a:ext cx="7114032" cy="12802"/>
           </a:xfrm>
           <a:prstGeom prst="rect">
             <a:avLst/>
@@ -6420,14 +6531,14 @@
       </p:sp>
       <p:sp>
         <p:nvSpPr>
-          <p:cNvPr id="14" name="Text 10"/>
-          <p:cNvSpPr/>
-          <p:nvPr/>
-        </p:nvSpPr>
-        <p:spPr>
-          <a:xfrm>
-            <a:off x="4800600" y="4123944"/>
-            <a:ext cx="1371600" cy="566928"/>
+          <p:cNvPr id="15" name="Text 11"/>
+          <p:cNvSpPr/>
+          <p:nvPr/>
+        </p:nvSpPr>
+        <p:spPr>
+          <a:xfrm>
+            <a:off x="4434840" y="4636008"/>
+            <a:ext cx="1325880" cy="548640"/>
           </a:xfrm>
           <a:prstGeom prst="rect">
             <a:avLst/>
@@ -6443,7 +6554,7 @@
               <a:buNone/>
             </a:pPr>
             <a:r>
-              <a:rPr lang="en-US" sz="3600" b="1" dirty="0">
+              <a:rPr lang="en-US" sz="3400" b="1" dirty="0">
                 <a:solidFill>
                   <a:srgbClr val="1D4ED8"/>
                 </a:solidFill>
@@ -6459,14 +6570,14 @@
       </p:sp>
       <p:sp>
         <p:nvSpPr>
-          <p:cNvPr id="15" name="Text 11"/>
-          <p:cNvSpPr/>
-          <p:nvPr/>
-        </p:nvSpPr>
-        <p:spPr>
-          <a:xfrm>
-            <a:off x="6263640" y="4215384"/>
-            <a:ext cx="5285232" cy="685800"/>
+          <p:cNvPr id="16" name="Text 12"/>
+          <p:cNvSpPr/>
+          <p:nvPr/>
+        </p:nvSpPr>
+        <p:spPr>
+          <a:xfrm>
+            <a:off x="5806440" y="4727448"/>
+            <a:ext cx="5742432" cy="685800"/>
           </a:xfrm>
           <a:prstGeom prst="rect">
             <a:avLst/>
@@ -6482,7 +6593,7 @@
               <a:buNone/>
             </a:pPr>
             <a:r>
-              <a:rPr lang="en-US" sz="1600" dirty="0">
+              <a:rPr lang="en-US" sz="1500" dirty="0">
                 <a:solidFill>
                   <a:srgbClr val="0F172A"/>
                 </a:solidFill>
@@ -6490,22 +6601,22 @@
                 <a:ea typeface="Arial" pitchFamily="34" charset="-122"/>
                 <a:cs typeface="Arial" pitchFamily="34" charset="-120"/>
               </a:rPr>
-              <a:t>of careers get five stars — it’s graded on a curve, like fund ratings, so stars compare instead of flatter</a:t>
-            </a:r>
-            <a:endParaRPr lang="en-US" sz="1500" dirty="0"/>
-          </a:p>
-        </p:txBody>
-      </p:sp>
-      <p:sp>
-        <p:nvSpPr>
-          <p:cNvPr id="16" name="Shape 12"/>
-          <p:cNvSpPr/>
-          <p:nvPr/>
-        </p:nvSpPr>
-        <p:spPr>
-          <a:xfrm>
-            <a:off x="4800600" y="5440680"/>
-            <a:ext cx="6748272" cy="12802"/>
+              <a:t>of careers get five stars — graded on a curve, like fund ratings, so stars compare instead of flatter</a:t>
+            </a:r>
+            <a:endParaRPr lang="en-US" sz="1500" dirty="0"/>
+          </a:p>
+        </p:txBody>
+      </p:sp>
+      <p:sp>
+        <p:nvSpPr>
+          <p:cNvPr id="17" name="Shape 13"/>
+          <p:cNvSpPr/>
+          <p:nvPr/>
+        </p:nvSpPr>
+        <p:spPr>
+          <a:xfrm>
+            <a:off x="4434840" y="5806440"/>
+            <a:ext cx="7114032" cy="12802"/>
           </a:xfrm>
           <a:prstGeom prst="rect">
             <a:avLst/>
@@ -6518,14 +6629,14 @@
       </p:sp>
       <p:sp>
         <p:nvSpPr>
-          <p:cNvPr id="17" name="Text 13"/>
-          <p:cNvSpPr/>
-          <p:nvPr/>
-        </p:nvSpPr>
-        <p:spPr>
-          <a:xfrm>
-            <a:off x="4800600" y="5623560"/>
-            <a:ext cx="6748272" cy="640080"/>
+          <p:cNvPr id="18" name="Text 14"/>
+          <p:cNvSpPr/>
+          <p:nvPr/>
+        </p:nvSpPr>
+        <p:spPr>
+          <a:xfrm>
+            <a:off x="4434840" y="5989320"/>
+            <a:ext cx="6858000" cy="640080"/>
           </a:xfrm>
           <a:prstGeom prst="rect">
             <a:avLst/>
@@ -6541,7 +6652,7 @@
               <a:buNone/>
             </a:pPr>
             <a:r>
-              <a:rPr lang="en-US" sz="1500" dirty="0">
+              <a:rPr lang="en-US" sz="1500" b="1" dirty="0">
                 <a:solidFill>
                   <a:srgbClr val="0F172A"/>
                 </a:solidFill>
@@ -6549,15 +6660,15 @@
                 <a:ea typeface="Arial" pitchFamily="34" charset="-122"/>
                 <a:cs typeface="Arial" pitchFamily="34" charset="-120"/>
               </a:rPr>
-              <a:t>The score is built from public data: how fast the career is growing, what it pays, and how much of the work AI can already do.</a:t>
-            </a:r>
-            <a:endParaRPr lang="en-US" sz="1500" dirty="0"/>
-          </a:p>
-        </p:txBody>
-      </p:sp>
-      <p:sp>
-        <p:nvSpPr>
-          <p:cNvPr id="18" name="Text 14"/>
+              <a:t>The score is public data, combined: growth, pay, and how much of the work AI can already do.</a:t>
+            </a:r>
+            <a:endParaRPr lang="en-US" sz="1500" dirty="0"/>
+          </a:p>
+        </p:txBody>
+      </p:sp>
+      <p:sp>
+        <p:nvSpPr>
+          <p:cNvPr id="19" name="Text 15"/>
           <p:cNvSpPr/>
           <p:nvPr/>
         </p:nvSpPr>

</xml_diff>

<commit_message>
Deck v8-v11, methodology and case-study copy pass
</commit_message>
<xml_diff>
--- a/docs/CareerStar-CapitalOne-v10.pptx
+++ b/docs/CareerStar-CapitalOne-v10.pptx
@@ -1220,7 +1220,8 @@
           <a:p>
             <a:r>
               <a:rPr lang="en-US" dirty="0"/>
-              <a:t>Let me show the product first so everything later has something to hang on. You type in the careers you're deciding between — say nursing versus software versus actuary — and each one gets a score out of 100. Higher means a stronger bet.
+              <a:t>First, what this project is and why I made it. Everyone I know is in the middle of picking a major or a career path, right while AI is reshuffling what those careers will look like. And when you search something like 'is nursing a safe career?', the internet gives you one of two things: a pep talk, or a doom score from a quiz — vibes, either way. What I wanted was the kind of answer an analyst gives about a stock: real numbers, named sources, and an honest 'it's close' when it's close. Nobody had built that, so I did.
+So here's what it is. You type in the careers you're deciding between — say nursing versus software versus actuary — and each one gets a score out of 100. Higher means a stronger bet, and the reasoning is shown, not hidden.
 Where do the numbers come from? The U.S. government, mostly. The Bureau of Labor Statistics — the agency that tracks the job market — publishes data on about 730 occupations: how many people work in each one, how fast it's expected to grow over the next decade, and what it typically pays. A second government database, O*NET, describes the skills each job actually uses day to day. And a published research study estimated, job by job, how much of the work today's AI could already do. My site combines those public sources — I didn't collect anything myself, which is the point: you can check my inputs.
 Why five formulas? Because my formula is one opinion about how to weigh all that, and reasonable people would weigh it differently. So the site ships five: the Standard one — my headline formula, reward marked down by AI risk. The Growth optimist — just growth and pay, deliberately ignoring AI, betting the official forecasts already account for it. The Defensive one — safety first: if AI hits hard, how sheltered is this career? The Efficiency one — reward per unit of risk; a career has to earn its risk. And the Plain average — it just averages everything, and it exists as the baseline: if my clever formula can't beat a plain average, I want to know. You can switch between them live, and when they disagree, that disagreement is real information about uncertainty.
 And the stars: they're graded on a curve, the way Morningstar rates mutual funds. Five stars doesn't mean 'nice job' — it means 'top 10 percent of all 730.' If most careers could get five stars, stars would mean nothing. Scarcity is what makes them information. (2:00)</a:t>
@@ -2432,7 +2433,7 @@
         </p:blipFill>
         <p:spPr>
           <a:xfrm>
-            <a:off x="5769864" y="1298448"/>
+            <a:off x="5769864" y="1207008"/>
             <a:ext cx="621792" cy="649224"/>
           </a:xfrm>
           <a:prstGeom prst="rect">
@@ -2444,30 +2445,28 @@
         <p:nvSpPr>
           <p:cNvPr id="3" name="Text 0"/>
           <p:cNvSpPr/>
-          <p:nvPr>
-            <p:ph idx="100" type="title" hasCustomPrompt="1"/>
-          </p:nvPr>
-        </p:nvSpPr>
-        <p:spPr>
-          <a:xfrm>
-            <a:off x="1527048" y="1965960"/>
-            <a:ext cx="9144000" cy="1005840"/>
-          </a:xfrm>
-          <a:prstGeom prst="rect">
-            <a:avLst/>
-          </a:prstGeom>
-          <a:noFill/>
-          <a:ln/>
-        </p:spPr>
-        <p:txBody>
-          <a:bodyPr wrap="square" lIns="0" tIns="0" rIns="0" bIns="0" rtlCol="0"/>
+          <p:nvPr/>
+        </p:nvSpPr>
+        <p:spPr>
+          <a:xfrm>
+            <a:off x="1069848" y="1965960"/>
+            <a:ext cx="10058400" cy="1920240"/>
+          </a:xfrm>
+          <a:prstGeom prst="rect">
+            <a:avLst/>
+          </a:prstGeom>
+          <a:noFill/>
+          <a:ln/>
+        </p:spPr>
+        <p:txBody>
+          <a:bodyPr wrap="square" lIns="0" tIns="0" rIns="0" bIns="0" rtlCol="0" anchor="t"/>
           <a:lstStyle/>
           <a:p>
             <a:pPr algn="ctr" indent="0" marL="0">
               <a:buNone/>
             </a:pPr>
             <a:r>
-              <a:rPr lang="en-US" sz="4400" b="1" dirty="0">
+              <a:rPr lang="en-US" sz="4200" b="1" dirty="0">
                 <a:solidFill>
                   <a:srgbClr val="FFFFFF"/>
                 </a:solidFill>
@@ -2475,56 +2474,55 @@
                 <a:ea typeface="Arial" pitchFamily="34" charset="-122"/>
                 <a:cs typeface="Arial" pitchFamily="34" charset="-120"/>
               </a:rPr>
-              <a:t>Rating careers like stocks</a:t>
-            </a:r>
-            <a:endParaRPr lang="en-US" sz="4400" dirty="0"/>
-          </a:p>
-        </p:txBody>
-      </p:sp>
-      <p:sp>
-        <p:nvSpPr>
-          <p:cNvPr id="4" name="Text 0"/>
-          <p:cNvSpPr/>
-          <p:nvPr>
-            <p:ph idx="101" type="body" hasCustomPrompt="1"/>
-          </p:nvPr>
-        </p:nvSpPr>
-        <p:spPr>
-          <a:xfrm>
-            <a:off x="1527048" y="3063240"/>
-            <a:ext cx="9144000" cy="822960"/>
-          </a:xfrm>
-          <a:prstGeom prst="rect">
-            <a:avLst/>
-          </a:prstGeom>
-          <a:noFill/>
-          <a:ln/>
-        </p:spPr>
-        <p:txBody>
-          <a:bodyPr wrap="square" lIns="0" tIns="0" rIns="0" bIns="0" rtlCol="0"/>
-          <a:lstStyle/>
+              <a:t>Rating careers like stocks:</a:t>
+            </a:r>
+            <a:endParaRPr lang="en-US" sz="4200" dirty="0"/>
+          </a:p>
           <a:p>
             <a:pPr algn="ctr" indent="0" marL="0">
               <a:buNone/>
             </a:pPr>
-            <a:r>
-              <a:rPr lang="en-US" sz="1800" dirty="0">
-                <a:solidFill>
-                  <a:srgbClr val="9DB0D9"/>
-                </a:solidFill>
-                <a:latin typeface="Arial" pitchFamily="34" charset="0"/>
-                <a:ea typeface="Arial" pitchFamily="34" charset="-122"/>
-                <a:cs typeface="Arial" pitchFamily="34" charset="-120"/>
-              </a:rPr>
-              <a:t>Exploring development with the BMAD AI agentic framework — and how to host a simple website on AWS.</a:t>
-            </a:r>
-            <a:endParaRPr lang="en-US" sz="1800" dirty="0"/>
-          </a:p>
-        </p:txBody>
-      </p:sp>
-      <p:sp>
-        <p:nvSpPr>
-          <p:cNvPr id="5" name="Shape 2"/>
+            <a:endParaRPr lang="en-US" sz="4200" dirty="0"/>
+          </a:p>
+          <a:p>
+            <a:pPr algn="ctr" indent="0" marL="0">
+              <a:buNone/>
+            </a:pPr>
+            <a:r>
+              <a:rPr lang="en-US" sz="2300" b="1" dirty="0">
+                <a:solidFill>
+                  <a:srgbClr val="E8EEFC"/>
+                </a:solidFill>
+                <a:latin typeface="Arial" pitchFamily="34" charset="0"/>
+                <a:ea typeface="Arial" pitchFamily="34" charset="-122"/>
+                <a:cs typeface="Arial" pitchFamily="34" charset="-120"/>
+              </a:rPr>
+              <a:t>Exploring development with the BMAD AI agentic framework,</a:t>
+            </a:r>
+            <a:endParaRPr lang="en-US" sz="4200" dirty="0"/>
+          </a:p>
+          <a:p>
+            <a:pPr algn="ctr" indent="0" marL="0">
+              <a:buNone/>
+            </a:pPr>
+            <a:r>
+              <a:rPr lang="en-US" sz="2300" b="1" dirty="0">
+                <a:solidFill>
+                  <a:srgbClr val="E8EEFC"/>
+                </a:solidFill>
+                <a:latin typeface="Arial" pitchFamily="34" charset="0"/>
+                <a:ea typeface="Arial" pitchFamily="34" charset="-122"/>
+                <a:cs typeface="Arial" pitchFamily="34" charset="-120"/>
+              </a:rPr>
+              <a:t>and how to host a simple website on AWS</a:t>
+            </a:r>
+            <a:endParaRPr lang="en-US" sz="4200" dirty="0"/>
+          </a:p>
+        </p:txBody>
+      </p:sp>
+      <p:sp>
+        <p:nvSpPr>
+          <p:cNvPr id="4" name="Shape 1"/>
           <p:cNvSpPr/>
           <p:nvPr/>
         </p:nvSpPr>
@@ -2544,7 +2542,7 @@
       </p:sp>
       <p:sp>
         <p:nvSpPr>
-          <p:cNvPr id="6" name="Text 3"/>
+          <p:cNvPr id="5" name="Text 2"/>
           <p:cNvSpPr/>
           <p:nvPr/>
         </p:nvSpPr>
@@ -2621,6 +2619,66 @@
               <a:t>Capital One · August 6, 2026</a:t>
             </a:r>
             <a:endParaRPr lang="en-US" sz="1500" dirty="0"/>
+          </a:p>
+        </p:txBody>
+      </p:sp>
+      <p:sp>
+        <p:nvSpPr>
+          <p:cNvPr id="7" name="Text 0"/>
+          <p:cNvSpPr/>
+          <p:nvPr>
+            <p:ph idx="100" type="title" hasCustomPrompt="1"/>
+          </p:nvPr>
+        </p:nvSpPr>
+        <p:spPr>
+          <a:xfrm>
+            <a:off x="1527048" y="1965960"/>
+            <a:ext cx="9144000" cy="1005840"/>
+          </a:xfrm>
+          <a:prstGeom prst="rect">
+            <a:avLst/>
+          </a:prstGeom>
+          <a:noFill/>
+          <a:ln/>
+        </p:spPr>
+        <p:txBody>
+          <a:bodyPr wrap="square" rtlCol="0"/>
+          <a:lstStyle/>
+          <a:p>
+            <a:pPr indent="0" marL="0">
+              <a:buNone/>
+            </a:pPr>
+            <a:endParaRPr lang="en-US" dirty="0"/>
+          </a:p>
+        </p:txBody>
+      </p:sp>
+      <p:sp>
+        <p:nvSpPr>
+          <p:cNvPr id="8" name="Text 0"/>
+          <p:cNvSpPr/>
+          <p:nvPr>
+            <p:ph idx="101" type="body" hasCustomPrompt="1"/>
+          </p:nvPr>
+        </p:nvSpPr>
+        <p:spPr>
+          <a:xfrm>
+            <a:off x="1527048" y="3063240"/>
+            <a:ext cx="9144000" cy="822960"/>
+          </a:xfrm>
+          <a:prstGeom prst="rect">
+            <a:avLst/>
+          </a:prstGeom>
+          <a:noFill/>
+          <a:ln/>
+        </p:spPr>
+        <p:txBody>
+          <a:bodyPr wrap="square" rtlCol="0"/>
+          <a:lstStyle/>
+          <a:p>
+            <a:pPr indent="0" marL="0">
+              <a:buNone/>
+            </a:pPr>
+            <a:endParaRPr lang="en-US" dirty="0"/>
           </a:p>
         </p:txBody>
       </p:sp>
@@ -6085,7 +6143,7 @@
                 <a:ea typeface="Arial" pitchFamily="34" charset="-122"/>
                 <a:cs typeface="Arial" pitchFamily="34" charset="-120"/>
               </a:rPr>
-              <a:t>02 · WHAT IT DOES</a:t>
+              <a:t>02 · WHAT IT IS, AND WHY</a:t>
             </a:r>
             <a:endParaRPr lang="en-US" sz="1400" dirty="0"/>
           </a:p>
@@ -6126,15 +6184,68 @@
                 <a:ea typeface="Arial" pitchFamily="34" charset="-122"/>
                 <a:cs typeface="Arial" pitchFamily="34" charset="-120"/>
               </a:rPr>
-              <a:t>Type in careers, get a score out of 100 for each</a:t>
+              <a:t>CareerStar: what it is, and why I built it</a:t>
             </a:r>
             <a:endParaRPr lang="en-US" sz="3000" dirty="0"/>
+          </a:p>
+        </p:txBody>
+      </p:sp>
+      <p:sp>
+        <p:nvSpPr>
+          <p:cNvPr id="5" name="Text 2"/>
+          <p:cNvSpPr/>
+          <p:nvPr/>
+        </p:nvSpPr>
+        <p:spPr>
+          <a:xfrm>
+            <a:off x="640080" y="1810512"/>
+            <a:ext cx="10911535" cy="603504"/>
+          </a:xfrm>
+          <a:prstGeom prst="rect">
+            <a:avLst/>
+          </a:prstGeom>
+          <a:noFill/>
+          <a:ln/>
+        </p:spPr>
+        <p:txBody>
+          <a:bodyPr wrap="square" lIns="0" tIns="0" rIns="0" bIns="0" rtlCol="0" anchor="t"/>
+          <a:lstStyle/>
+          <a:p>
+            <a:pPr algn="l" indent="0" marL="0">
+              <a:buNone/>
+            </a:pPr>
+            <a:r>
+              <a:rPr lang="en-US" sz="1500" dirty="0">
+                <a:solidFill>
+                  <a:srgbClr val="64748B"/>
+                </a:solidFill>
+                <a:latin typeface="Arial" pitchFamily="34" charset="0"/>
+                <a:ea typeface="Arial" pitchFamily="34" charset="-122"/>
+                <a:cs typeface="Arial" pitchFamily="34" charset="-120"/>
+              </a:rPr>
+              <a:t>People my age are picking careers while AI reshuffles them — and the internet’s answers are either pep talks or doom scores. </a:t>
+            </a:r>
+            <a:pPr algn="l" indent="0" marL="0">
+              <a:buNone/>
+            </a:pPr>
+            <a:r>
+              <a:rPr lang="en-US" sz="1500" b="1" dirty="0">
+                <a:solidFill>
+                  <a:srgbClr val="0F172A"/>
+                </a:solidFill>
+                <a:latin typeface="Arial" pitchFamily="34" charset="0"/>
+                <a:ea typeface="Arial" pitchFamily="34" charset="-122"/>
+                <a:cs typeface="Arial" pitchFamily="34" charset="-120"/>
+              </a:rPr>
+              <a:t>So I built the tool I wanted: type in the careers you’re weighing, get a score out of 100 for each, with the reasoning shown.</a:t>
+            </a:r>
+            <a:endParaRPr lang="en-US" sz="1500" dirty="0"/>
           </a:p>
         </p:txBody>
       </p:sp>
       <p:pic>
         <p:nvPicPr>
-          <p:cNvPr id="5" name="Image 1" descr="preencoded.png">    </p:cNvPr>
+          <p:cNvPr id="6" name="Image 1" descr="preencoded.png">    </p:cNvPr>
           <p:cNvPicPr>
             <a:picLocks noChangeAspect="1"/>
           </p:cNvPicPr>
@@ -6148,8 +6259,8 @@
         </p:blipFill>
         <p:spPr>
           <a:xfrm>
-            <a:off x="640080" y="1828800"/>
-            <a:ext cx="3890648" cy="4160520"/>
+            <a:off x="640080" y="2514600"/>
+            <a:ext cx="3377596" cy="3611880"/>
           </a:xfrm>
           <a:prstGeom prst="rect">
             <a:avLst/>
@@ -6158,14 +6269,14 @@
       </p:pic>
       <p:sp>
         <p:nvSpPr>
-          <p:cNvPr id="6" name="Shape 2"/>
-          <p:cNvSpPr/>
-          <p:nvPr/>
-        </p:nvSpPr>
-        <p:spPr>
-          <a:xfrm>
-            <a:off x="621792" y="1810512"/>
-            <a:ext cx="3927224" cy="4197096"/>
+          <p:cNvPr id="7" name="Shape 3"/>
+          <p:cNvSpPr/>
+          <p:nvPr/>
+        </p:nvSpPr>
+        <p:spPr>
+          <a:xfrm>
+            <a:off x="621792" y="2496312"/>
+            <a:ext cx="3414172" cy="3648456"/>
           </a:xfrm>
           <a:prstGeom prst="rect">
             <a:avLst/>
@@ -6185,14 +6296,14 @@
       </p:sp>
       <p:sp>
         <p:nvSpPr>
-          <p:cNvPr id="7" name="Text 3"/>
-          <p:cNvSpPr/>
-          <p:nvPr/>
-        </p:nvSpPr>
-        <p:spPr>
-          <a:xfrm>
-            <a:off x="640080" y="6053328"/>
-            <a:ext cx="4805048" cy="274320"/>
+          <p:cNvPr id="8" name="Text 4"/>
+          <p:cNvSpPr/>
+          <p:nvPr/>
+        </p:nvSpPr>
+        <p:spPr>
+          <a:xfrm>
+            <a:off x="640080" y="6217920"/>
+            <a:ext cx="3560476" cy="274320"/>
           </a:xfrm>
           <a:prstGeom prst="rect">
             <a:avLst/>
@@ -6216,22 +6327,22 @@
                 <a:ea typeface="Arial" pitchFamily="34" charset="-122"/>
                 <a:cs typeface="Arial" pitchFamily="34" charset="-120"/>
               </a:rPr>
-              <a:t>ashleylibasci.com/rate — the real site, as it looks today</a:t>
-            </a:r>
-            <a:endParaRPr lang="en-US" sz="1500" dirty="0"/>
-          </a:p>
-        </p:txBody>
-      </p:sp>
-      <p:sp>
-        <p:nvSpPr>
-          <p:cNvPr id="8" name="Text 4"/>
-          <p:cNvSpPr/>
-          <p:nvPr/>
-        </p:nvSpPr>
-        <p:spPr>
-          <a:xfrm>
-            <a:off x="4800600" y="2075688"/>
-            <a:ext cx="1371600" cy="566928"/>
+              <a:t>ashleylibasci.com/rate — the live site</a:t>
+            </a:r>
+            <a:endParaRPr lang="en-US" sz="1500" dirty="0"/>
+          </a:p>
+        </p:txBody>
+      </p:sp>
+      <p:sp>
+        <p:nvSpPr>
+          <p:cNvPr id="9" name="Text 5"/>
+          <p:cNvSpPr/>
+          <p:nvPr/>
+        </p:nvSpPr>
+        <p:spPr>
+          <a:xfrm>
+            <a:off x="4434840" y="2624328"/>
+            <a:ext cx="1325880" cy="548640"/>
           </a:xfrm>
           <a:prstGeom prst="rect">
             <a:avLst/>
@@ -6247,7 +6358,7 @@
               <a:buNone/>
             </a:pPr>
             <a:r>
-              <a:rPr lang="en-US" sz="3600" b="1" dirty="0">
+              <a:rPr lang="en-US" sz="3400" b="1" dirty="0">
                 <a:solidFill>
                   <a:srgbClr val="1D4ED8"/>
                 </a:solidFill>
@@ -6263,14 +6374,14 @@
       </p:sp>
       <p:sp>
         <p:nvSpPr>
-          <p:cNvPr id="9" name="Text 5"/>
-          <p:cNvSpPr/>
-          <p:nvPr/>
-        </p:nvSpPr>
-        <p:spPr>
-          <a:xfrm>
-            <a:off x="6263640" y="2167128"/>
-            <a:ext cx="5285232" cy="685800"/>
+          <p:cNvPr id="10" name="Text 6"/>
+          <p:cNvSpPr/>
+          <p:nvPr/>
+        </p:nvSpPr>
+        <p:spPr>
+          <a:xfrm>
+            <a:off x="5806440" y="2715768"/>
+            <a:ext cx="5742432" cy="685800"/>
           </a:xfrm>
           <a:prstGeom prst="rect">
             <a:avLst/>
@@ -6286,7 +6397,7 @@
               <a:buNone/>
             </a:pPr>
             <a:r>
-              <a:rPr lang="en-US" sz="1600" dirty="0">
+              <a:rPr lang="en-US" sz="1500" dirty="0">
                 <a:solidFill>
                   <a:srgbClr val="0F172A"/>
                 </a:solidFill>
@@ -6294,22 +6405,22 @@
                 <a:ea typeface="Arial" pitchFamily="34" charset="-122"/>
                 <a:cs typeface="Arial" pitchFamily="34" charset="-120"/>
               </a:rPr>
-              <a:t>occupations scored — every job the U.S. Labor Department publishes numbers on: how many people do it, expected growth, typical pay</a:t>
-            </a:r>
-            <a:endParaRPr lang="en-US" sz="1500" dirty="0"/>
-          </a:p>
-        </p:txBody>
-      </p:sp>
-      <p:sp>
-        <p:nvSpPr>
-          <p:cNvPr id="10" name="Shape 6"/>
-          <p:cNvSpPr/>
-          <p:nvPr/>
-        </p:nvSpPr>
-        <p:spPr>
-          <a:xfrm>
-            <a:off x="4800600" y="2953512"/>
-            <a:ext cx="6748272" cy="12802"/>
+              <a:t>occupations scored — every job the U.S. Labor Department publishes numbers on: headcount, expected growth, typical pay</a:t>
+            </a:r>
+            <a:endParaRPr lang="en-US" sz="1500" dirty="0"/>
+          </a:p>
+        </p:txBody>
+      </p:sp>
+      <p:sp>
+        <p:nvSpPr>
+          <p:cNvPr id="11" name="Shape 7"/>
+          <p:cNvSpPr/>
+          <p:nvPr/>
+        </p:nvSpPr>
+        <p:spPr>
+          <a:xfrm>
+            <a:off x="4434840" y="3483864"/>
+            <a:ext cx="7114032" cy="12802"/>
           </a:xfrm>
           <a:prstGeom prst="rect">
             <a:avLst/>
@@ -6322,14 +6433,14 @@
       </p:sp>
       <p:sp>
         <p:nvSpPr>
-          <p:cNvPr id="11" name="Text 7"/>
-          <p:cNvSpPr/>
-          <p:nvPr/>
-        </p:nvSpPr>
-        <p:spPr>
-          <a:xfrm>
-            <a:off x="4800600" y="3099816"/>
-            <a:ext cx="1371600" cy="566928"/>
+          <p:cNvPr id="12" name="Text 8"/>
+          <p:cNvSpPr/>
+          <p:nvPr/>
+        </p:nvSpPr>
+        <p:spPr>
+          <a:xfrm>
+            <a:off x="4434840" y="3630168"/>
+            <a:ext cx="1325880" cy="548640"/>
           </a:xfrm>
           <a:prstGeom prst="rect">
             <a:avLst/>
@@ -6345,7 +6456,7 @@
               <a:buNone/>
             </a:pPr>
             <a:r>
-              <a:rPr lang="en-US" sz="3600" b="1" dirty="0">
+              <a:rPr lang="en-US" sz="3400" b="1" dirty="0">
                 <a:solidFill>
                   <a:srgbClr val="1D4ED8"/>
                 </a:solidFill>
@@ -6361,14 +6472,14 @@
       </p:sp>
       <p:sp>
         <p:nvSpPr>
-          <p:cNvPr id="12" name="Text 8"/>
-          <p:cNvSpPr/>
-          <p:nvPr/>
-        </p:nvSpPr>
-        <p:spPr>
-          <a:xfrm>
-            <a:off x="6263640" y="3191256"/>
-            <a:ext cx="5285232" cy="685800"/>
+          <p:cNvPr id="13" name="Text 9"/>
+          <p:cNvSpPr/>
+          <p:nvPr/>
+        </p:nvSpPr>
+        <p:spPr>
+          <a:xfrm>
+            <a:off x="5806440" y="3721608"/>
+            <a:ext cx="5742432" cy="685800"/>
           </a:xfrm>
           <a:prstGeom prst="rect">
             <a:avLst/>
@@ -6384,7 +6495,7 @@
               <a:buNone/>
             </a:pPr>
             <a:r>
-              <a:rPr lang="en-US" sz="1600" dirty="0">
+              <a:rPr lang="en-US" sz="1500" dirty="0">
                 <a:solidFill>
                   <a:srgbClr val="0F172A"/>
                 </a:solidFill>
@@ -6400,14 +6511,14 @@
       </p:sp>
       <p:sp>
         <p:nvSpPr>
-          <p:cNvPr id="13" name="Shape 9"/>
-          <p:cNvSpPr/>
-          <p:nvPr/>
-        </p:nvSpPr>
-        <p:spPr>
-          <a:xfrm>
-            <a:off x="4800600" y="3977640"/>
-            <a:ext cx="6748272" cy="12802"/>
+          <p:cNvPr id="14" name="Shape 10"/>
+          <p:cNvSpPr/>
+          <p:nvPr/>
+        </p:nvSpPr>
+        <p:spPr>
+          <a:xfrm>
+            <a:off x="4434840" y="4489704"/>
+            <a:ext cx="7114032" cy="12802"/>
           </a:xfrm>
           <a:prstGeom prst="rect">
             <a:avLst/>
@@ -6420,14 +6531,14 @@
       </p:sp>
       <p:sp>
         <p:nvSpPr>
-          <p:cNvPr id="14" name="Text 10"/>
-          <p:cNvSpPr/>
-          <p:nvPr/>
-        </p:nvSpPr>
-        <p:spPr>
-          <a:xfrm>
-            <a:off x="4800600" y="4123944"/>
-            <a:ext cx="1371600" cy="566928"/>
+          <p:cNvPr id="15" name="Text 11"/>
+          <p:cNvSpPr/>
+          <p:nvPr/>
+        </p:nvSpPr>
+        <p:spPr>
+          <a:xfrm>
+            <a:off x="4434840" y="4636008"/>
+            <a:ext cx="1325880" cy="548640"/>
           </a:xfrm>
           <a:prstGeom prst="rect">
             <a:avLst/>
@@ -6443,7 +6554,7 @@
               <a:buNone/>
             </a:pPr>
             <a:r>
-              <a:rPr lang="en-US" sz="3600" b="1" dirty="0">
+              <a:rPr lang="en-US" sz="3400" b="1" dirty="0">
                 <a:solidFill>
                   <a:srgbClr val="1D4ED8"/>
                 </a:solidFill>
@@ -6459,14 +6570,14 @@
       </p:sp>
       <p:sp>
         <p:nvSpPr>
-          <p:cNvPr id="15" name="Text 11"/>
-          <p:cNvSpPr/>
-          <p:nvPr/>
-        </p:nvSpPr>
-        <p:spPr>
-          <a:xfrm>
-            <a:off x="6263640" y="4215384"/>
-            <a:ext cx="5285232" cy="685800"/>
+          <p:cNvPr id="16" name="Text 12"/>
+          <p:cNvSpPr/>
+          <p:nvPr/>
+        </p:nvSpPr>
+        <p:spPr>
+          <a:xfrm>
+            <a:off x="5806440" y="4727448"/>
+            <a:ext cx="5742432" cy="685800"/>
           </a:xfrm>
           <a:prstGeom prst="rect">
             <a:avLst/>
@@ -6482,7 +6593,7 @@
               <a:buNone/>
             </a:pPr>
             <a:r>
-              <a:rPr lang="en-US" sz="1600" dirty="0">
+              <a:rPr lang="en-US" sz="1500" dirty="0">
                 <a:solidFill>
                   <a:srgbClr val="0F172A"/>
                 </a:solidFill>
@@ -6490,22 +6601,22 @@
                 <a:ea typeface="Arial" pitchFamily="34" charset="-122"/>
                 <a:cs typeface="Arial" pitchFamily="34" charset="-120"/>
               </a:rPr>
-              <a:t>of careers get five stars — it’s graded on a curve, like fund ratings, so stars compare instead of flatter</a:t>
-            </a:r>
-            <a:endParaRPr lang="en-US" sz="1500" dirty="0"/>
-          </a:p>
-        </p:txBody>
-      </p:sp>
-      <p:sp>
-        <p:nvSpPr>
-          <p:cNvPr id="16" name="Shape 12"/>
-          <p:cNvSpPr/>
-          <p:nvPr/>
-        </p:nvSpPr>
-        <p:spPr>
-          <a:xfrm>
-            <a:off x="4800600" y="5440680"/>
-            <a:ext cx="6748272" cy="12802"/>
+              <a:t>of careers get five stars — graded on a curve, like fund ratings, so stars compare instead of flatter</a:t>
+            </a:r>
+            <a:endParaRPr lang="en-US" sz="1500" dirty="0"/>
+          </a:p>
+        </p:txBody>
+      </p:sp>
+      <p:sp>
+        <p:nvSpPr>
+          <p:cNvPr id="17" name="Shape 13"/>
+          <p:cNvSpPr/>
+          <p:nvPr/>
+        </p:nvSpPr>
+        <p:spPr>
+          <a:xfrm>
+            <a:off x="4434840" y="5806440"/>
+            <a:ext cx="7114032" cy="12802"/>
           </a:xfrm>
           <a:prstGeom prst="rect">
             <a:avLst/>
@@ -6518,14 +6629,14 @@
       </p:sp>
       <p:sp>
         <p:nvSpPr>
-          <p:cNvPr id="17" name="Text 13"/>
-          <p:cNvSpPr/>
-          <p:nvPr/>
-        </p:nvSpPr>
-        <p:spPr>
-          <a:xfrm>
-            <a:off x="4800600" y="5623560"/>
-            <a:ext cx="6748272" cy="640080"/>
+          <p:cNvPr id="18" name="Text 14"/>
+          <p:cNvSpPr/>
+          <p:nvPr/>
+        </p:nvSpPr>
+        <p:spPr>
+          <a:xfrm>
+            <a:off x="4434840" y="5989320"/>
+            <a:ext cx="6858000" cy="640080"/>
           </a:xfrm>
           <a:prstGeom prst="rect">
             <a:avLst/>
@@ -6541,7 +6652,7 @@
               <a:buNone/>
             </a:pPr>
             <a:r>
-              <a:rPr lang="en-US" sz="1500" dirty="0">
+              <a:rPr lang="en-US" sz="1500" b="1" dirty="0">
                 <a:solidFill>
                   <a:srgbClr val="0F172A"/>
                 </a:solidFill>
@@ -6549,15 +6660,15 @@
                 <a:ea typeface="Arial" pitchFamily="34" charset="-122"/>
                 <a:cs typeface="Arial" pitchFamily="34" charset="-120"/>
               </a:rPr>
-              <a:t>The score is built from public data: how fast the career is growing, what it pays, and how much of the work AI can already do.</a:t>
-            </a:r>
-            <a:endParaRPr lang="en-US" sz="1500" dirty="0"/>
-          </a:p>
-        </p:txBody>
-      </p:sp>
-      <p:sp>
-        <p:nvSpPr>
-          <p:cNvPr id="18" name="Text 14"/>
+              <a:t>The score is public data, combined: growth, pay, and how much of the work AI can already do.</a:t>
+            </a:r>
+            <a:endParaRPr lang="en-US" sz="1500" dirty="0"/>
+          </a:p>
+        </p:txBody>
+      </p:sp>
+      <p:sp>
+        <p:nvSpPr>
+          <p:cNvPr id="19" name="Text 15"/>
           <p:cNvSpPr/>
           <p:nvPr/>
         </p:nvSpPr>

</xml_diff>